<commit_message>
Update Uncertainty Budget Explainer for Counterfactual Headquarters
- Rename from Greenfield Municipal Center to Counterfactual Headquarters
- Reduce from 4 ECMs to 2 ECMs; repurpose ECM-3/4 card slots for:
  Interactive Effects (gas increase from reduced lighting heat) and
  NRA: Community Room expansion (month 9, ontological uncertainty)
- Update algorithm table: 5 rows keyed to 2-ECM building
- Revise diminishing returns milestones ($1.5k / $5k / $10k / $20k+)
- Update slide 7 examples: remove statssheets/bayesian-mv-module/entropy-audit-tool refs
- Remove mnvexample.streamlit.app from footer

Co-Authored-By: Claude Opus 4.6 <noreply@anthropic.com>
</commit_message>
<xml_diff>
--- a/MV_Uncertainty_Budget_Explainer.pptx
+++ b/MV_Uncertainty_Budget_Explainer.pptx
@@ -1807,6 +1807,10 @@
           </a:solidFill>
           <a:ln/>
         </p:spPr>
+        <p:txBody>
+          <a:bodyPr/>
+          <a:p/>
+        </p:txBody>
       </p:sp>
       <p:pic>
         <p:nvPicPr>
@@ -1950,7 +1954,7 @@
                 <a:ea typeface="Calibri" pitchFamily="34" charset="-122"/>
                 <a:cs typeface="Calibri" pitchFamily="34" charset="-120"/>
               </a:rPr>
-              <a:t>for the Greenfield Municipal Center</a:t>
+              <a:t>for the Counterfactual Headquarters</a:t>
             </a:r>
             <a:endParaRPr lang="en-US" sz="1800" dirty="0"/>
           </a:p>
@@ -1975,6 +1979,10 @@
           </a:solidFill>
           <a:ln/>
         </p:spPr>
+        <p:txBody>
+          <a:bodyPr/>
+          <a:p/>
+        </p:txBody>
       </p:sp>
       <p:sp>
         <p:nvSpPr>
@@ -3917,6 +3925,10 @@
           </a:solidFill>
           <a:ln/>
         </p:spPr>
+        <p:txBody>
+          <a:bodyPr/>
+          <a:p/>
+        </p:txBody>
       </p:sp>
       <p:sp>
         <p:nvSpPr>
@@ -3951,7 +3963,7 @@
                 <a:ea typeface="Georgia" pitchFamily="34" charset="-122"/>
                 <a:cs typeface="Georgia" pitchFamily="34" charset="-120"/>
               </a:rPr>
-              <a:t>Greenfield Municipal Center — 4 ECMs</a:t>
+              <a:t>Counterfactual Headquarters — 2 ECMs</a:t>
             </a:r>
             <a:endParaRPr lang="en-US" sz="2600" dirty="0"/>
           </a:p>
@@ -3990,7 +4002,7 @@
                 <a:ea typeface="Calibri" pitchFamily="34" charset="-122"/>
                 <a:cs typeface="Calibri" pitchFamily="34" charset="-120"/>
               </a:rPr>
-              <a:t>62,000 sq ft  |  Mid-Atlantic  |  15-year ESPC  |  Combined savings: 122,390 kWh (10.5%)</a:t>
+              <a:t>12,000 sq ft  |  Mid-Atlantic  |  Zone 4A  |  Gas heat, DX cooling</a:t>
             </a:r>
             <a:endParaRPr lang="en-US" sz="1200" dirty="0"/>
           </a:p>
@@ -4022,6 +4034,10 @@
             </a:outerShdw>
           </a:effectLst>
         </p:spPr>
+        <p:txBody>
+          <a:bodyPr/>
+          <a:p/>
+        </p:txBody>
       </p:sp>
       <p:pic>
         <p:nvPicPr>
@@ -4119,7 +4135,7 @@
                 <a:ea typeface="Consolas" pitchFamily="34" charset="-122"/>
                 <a:cs typeface="Consolas" pitchFamily="34" charset="-120"/>
               </a:rPr>
-              <a:t>157,146 kWh</a:t>
+              <a:t>~17,500 kWh</a:t>
             </a:r>
             <a:endParaRPr lang="en-US" sz="1100" dirty="0"/>
           </a:p>
@@ -4181,7 +4197,7 @@
                 <a:ea typeface="Calibri" pitchFamily="34" charset="-122"/>
                 <a:cs typeface="Calibri" pitchFamily="34" charset="-120"/>
               </a:rPr>
-              <a:t>Key Parameter (Option A)</a:t>
+              <a:t>Key Parameter Measurement (cf. Option A)</a:t>
             </a:r>
             <a:endParaRPr lang="en-US" sz="1000" dirty="0"/>
           </a:p>
@@ -4206,6 +4222,10 @@
           </a:solidFill>
           <a:ln/>
         </p:spPr>
+        <p:txBody>
+          <a:bodyPr/>
+          <a:p/>
+        </p:txBody>
       </p:sp>
       <p:sp>
         <p:nvSpPr>
@@ -4334,6 +4354,10 @@
             </a:outerShdw>
           </a:effectLst>
         </p:spPr>
+        <p:txBody>
+          <a:bodyPr/>
+          <a:p/>
+        </p:txBody>
       </p:sp>
       <p:pic>
         <p:nvPicPr>
@@ -4392,7 +4416,7 @@
                 <a:ea typeface="Calibri" pitchFamily="34" charset="-122"/>
                 <a:cs typeface="Calibri" pitchFamily="34" charset="-120"/>
               </a:rPr>
-              <a:t>ECM-2: Chiller/DX</a:t>
+              <a:t>ECM-2: HVAC Controls</a:t>
             </a:r>
             <a:endParaRPr lang="en-US" sz="1300" dirty="0"/>
           </a:p>
@@ -4431,7 +4455,7 @@
                 <a:ea typeface="Consolas" pitchFamily="34" charset="-122"/>
                 <a:cs typeface="Consolas" pitchFamily="34" charset="-120"/>
               </a:rPr>
-              <a:t>Combined w/ WF</a:t>
+              <a:t>Whole facility savings</a:t>
             </a:r>
             <a:endParaRPr lang="en-US" sz="1100" dirty="0"/>
           </a:p>
@@ -4493,7 +4517,7 @@
                 <a:ea typeface="Calibri" pitchFamily="34" charset="-122"/>
                 <a:cs typeface="Calibri" pitchFamily="34" charset="-120"/>
               </a:rPr>
-              <a:t>(Student decides)</a:t>
+              <a:t>Inverse Model (cf. Option C)</a:t>
             </a:r>
             <a:endParaRPr lang="en-US" sz="1000" dirty="0"/>
           </a:p>
@@ -4518,6 +4542,10 @@
           </a:solidFill>
           <a:ln/>
         </p:spPr>
+        <p:txBody>
+          <a:bodyPr/>
+          <a:p/>
+        </p:txBody>
       </p:sp>
       <p:sp>
         <p:nvSpPr>
@@ -4552,7 +4580,7 @@
                 <a:ea typeface="Calibri" pitchFamily="34" charset="-122"/>
                 <a:cs typeface="Calibri" pitchFamily="34" charset="-120"/>
               </a:rPr>
-              <a:t>Uncertainty: MEDIUM</a:t>
+              <a:t>Uncertainty: HIGH</a:t>
             </a:r>
             <a:endParaRPr lang="en-US" sz="1000" dirty="0"/>
           </a:p>
@@ -4594,7 +4622,7 @@
                 <a:ea typeface="Calibri" pitchFamily="34" charset="-122"/>
                 <a:cs typeface="Calibri" pitchFamily="34" charset="-120"/>
               </a:rPr>
-              <a:t>COP from nameplate;</a:t>
+              <a:t>Controls savings invisible</a:t>
             </a:r>
             <a:endParaRPr lang="en-US" sz="1000" dirty="0"/>
           </a:p>
@@ -4614,7 +4642,7 @@
                 <a:ea typeface="Calibri" pitchFamily="34" charset="-122"/>
                 <a:cs typeface="Calibri" pitchFamily="34" charset="-120"/>
               </a:rPr>
-              <a:t>interactive effects present.</a:t>
+              <a:t>at meter. Inverse model required.</a:t>
             </a:r>
             <a:endParaRPr lang="en-US" sz="1000" dirty="0"/>
           </a:p>
@@ -4646,6 +4674,10 @@
             </a:outerShdw>
           </a:effectLst>
         </p:spPr>
+        <p:txBody>
+          <a:bodyPr/>
+          <a:p/>
+        </p:txBody>
       </p:sp>
       <p:pic>
         <p:nvPicPr>
@@ -4704,7 +4736,7 @@
                 <a:ea typeface="Calibri" pitchFamily="34" charset="-122"/>
                 <a:cs typeface="Calibri" pitchFamily="34" charset="-120"/>
               </a:rPr>
-              <a:t>ECM-3: Roof Insulation</a:t>
+              <a:t>Gas Increase</a:t>
             </a:r>
             <a:endParaRPr lang="en-US" sz="1300" dirty="0"/>
           </a:p>
@@ -4743,7 +4775,7 @@
                 <a:ea typeface="Consolas" pitchFamily="34" charset="-122"/>
                 <a:cs typeface="Consolas" pitchFamily="34" charset="-120"/>
               </a:rPr>
-              <a:t>Combined w/ WF</a:t>
+              <a:t>Interactive effect</a:t>
             </a:r>
             <a:endParaRPr lang="en-US" sz="1100" dirty="0"/>
           </a:p>
@@ -4785,7 +4817,7 @@
                 <a:ea typeface="Calibri" pitchFamily="34" charset="-122"/>
                 <a:cs typeface="Calibri" pitchFamily="34" charset="-120"/>
               </a:rPr>
-              <a:t>Whole Facility</a:t>
+              <a:t>Expected — less lighting</a:t>
             </a:r>
             <a:endParaRPr lang="en-US" sz="1000" dirty="0"/>
           </a:p>
@@ -4805,7 +4837,7 @@
                 <a:ea typeface="Calibri" pitchFamily="34" charset="-122"/>
                 <a:cs typeface="Calibri" pitchFamily="34" charset="-120"/>
               </a:rPr>
-              <a:t>Inverse Model (Option C)</a:t>
+              <a:t>heat → more gas heating</a:t>
             </a:r>
             <a:endParaRPr lang="en-US" sz="1000" dirty="0"/>
           </a:p>
@@ -4830,6 +4862,10 @@
           </a:solidFill>
           <a:ln/>
         </p:spPr>
+        <p:txBody>
+          <a:bodyPr/>
+          <a:p/>
+        </p:txBody>
       </p:sp>
       <p:sp>
         <p:nvSpPr>
@@ -4864,7 +4900,7 @@
                 <a:ea typeface="Calibri" pitchFamily="34" charset="-122"/>
                 <a:cs typeface="Calibri" pitchFamily="34" charset="-120"/>
               </a:rPr>
-              <a:t>Uncertainty: HIGH</a:t>
+              <a:t>Uncertainty: MEDIUM</a:t>
             </a:r>
             <a:endParaRPr lang="en-US" sz="1000" dirty="0"/>
           </a:p>
@@ -4906,7 +4942,7 @@
                 <a:ea typeface="Calibri" pitchFamily="34" charset="-122"/>
                 <a:cs typeface="Calibri" pitchFamily="34" charset="-120"/>
               </a:rPr>
-              <a:t>Cannot isolate. Only 12</a:t>
+              <a:t>Explain to building owner:</a:t>
             </a:r>
             <a:endParaRPr lang="en-US" sz="1000" dirty="0"/>
           </a:p>
@@ -4926,7 +4962,7 @@
                 <a:ea typeface="Calibri" pitchFamily="34" charset="-122"/>
                 <a:cs typeface="Calibri" pitchFamily="34" charset="-120"/>
               </a:rPr>
-              <a:t>monthly points for regression.</a:t>
+              <a:t>model makes it legible.</a:t>
             </a:r>
             <a:endParaRPr lang="en-US" sz="1000" dirty="0"/>
           </a:p>
@@ -4958,6 +4994,10 @@
             </a:outerShdw>
           </a:effectLst>
         </p:spPr>
+        <p:txBody>
+          <a:bodyPr/>
+          <a:p/>
+        </p:txBody>
       </p:sp>
       <p:pic>
         <p:nvPicPr>
@@ -5016,7 +5056,7 @@
                 <a:ea typeface="Calibri" pitchFamily="34" charset="-122"/>
                 <a:cs typeface="Calibri" pitchFamily="34" charset="-120"/>
               </a:rPr>
-              <a:t>ECM-4: VFDs on AHUs</a:t>
+              <a:t>NRA: Community Room</a:t>
             </a:r>
             <a:endParaRPr lang="en-US" sz="1300" dirty="0"/>
           </a:p>
@@ -5055,7 +5095,7 @@
                 <a:ea typeface="Consolas" pitchFamily="34" charset="-122"/>
                 <a:cs typeface="Consolas" pitchFamily="34" charset="-120"/>
               </a:rPr>
-              <a:t>Varies w/ load</a:t>
+              <a:t>Month 9 expansion</a:t>
             </a:r>
             <a:endParaRPr lang="en-US" sz="1100" dirty="0"/>
           </a:p>
@@ -5097,7 +5137,7 @@
                 <a:ea typeface="Calibri" pitchFamily="34" charset="-122"/>
                 <a:cs typeface="Calibri" pitchFamily="34" charset="-120"/>
               </a:rPr>
-              <a:t>Retrofit Isolation</a:t>
+              <a:t>Pre-documented trigger</a:t>
             </a:r>
             <a:endParaRPr lang="en-US" sz="1000" dirty="0"/>
           </a:p>
@@ -5117,7 +5157,7 @@
                 <a:ea typeface="Calibri" pitchFamily="34" charset="-122"/>
                 <a:cs typeface="Calibri" pitchFamily="34" charset="-120"/>
               </a:rPr>
-              <a:t>Continuous (Option B)</a:t>
+              <a:t>Engineering estimate</a:t>
             </a:r>
             <a:endParaRPr lang="en-US" sz="1000" dirty="0"/>
           </a:p>
@@ -5142,6 +5182,10 @@
           </a:solidFill>
           <a:ln/>
         </p:spPr>
+        <p:txBody>
+          <a:bodyPr/>
+          <a:p/>
+        </p:txBody>
       </p:sp>
       <p:sp>
         <p:nvSpPr>
@@ -5176,7 +5220,7 @@
                 <a:ea typeface="Calibri" pitchFamily="34" charset="-122"/>
                 <a:cs typeface="Calibri" pitchFamily="34" charset="-120"/>
               </a:rPr>
-              <a:t>Uncertainty: MEDIUM</a:t>
+              <a:t>Uncertainty: CRITICAL</a:t>
             </a:r>
             <a:endParaRPr lang="en-US" sz="1000" dirty="0"/>
           </a:p>
@@ -5218,7 +5262,7 @@
                 <a:ea typeface="Calibri" pitchFamily="34" charset="-122"/>
                 <a:cs typeface="Calibri" pitchFamily="34" charset="-120"/>
               </a:rPr>
-              <a:t>672 hourly points; fan law</a:t>
+              <a:t>Without NRA: controls savings</a:t>
             </a:r>
             <a:endParaRPr lang="en-US" sz="1000" dirty="0"/>
           </a:p>
@@ -5238,7 +5282,7 @@
                 <a:ea typeface="Calibri" pitchFamily="34" charset="-122"/>
                 <a:cs typeface="Calibri" pitchFamily="34" charset="-120"/>
               </a:rPr>
-              <a:t>validation. Load-dependent.</a:t>
+              <a:t>appear negative. With NRA: real.</a:t>
             </a:r>
             <a:endParaRPr lang="en-US" sz="1000" dirty="0"/>
           </a:p>
@@ -5295,6 +5339,10 @@
           </a:solidFill>
           <a:ln/>
         </p:spPr>
+        <p:txBody>
+          <a:bodyPr/>
+          <a:p/>
+        </p:txBody>
       </p:sp>
       <p:sp>
         <p:nvSpPr>
@@ -5329,7 +5377,7 @@
                 <a:ea typeface="Georgia" pitchFamily="34" charset="-122"/>
                 <a:cs typeface="Georgia" pitchFamily="34" charset="-120"/>
               </a:rPr>
-              <a:t>Applying the Algorithm to Greenfield</a:t>
+              <a:t>Applying the Algorithm to Counterfactual Headquarters</a:t>
             </a:r>
             <a:endParaRPr lang="en-US" sz="2600" dirty="0"/>
           </a:p>
@@ -5856,7 +5904,7 @@
                           <a:ea typeface="Calibri" pitchFamily="34" charset="-122"/>
                           <a:cs typeface="Calibri" pitchFamily="34" charset="-120"/>
                         </a:rPr>
-                        <a:t>(620 fixtures, sampling plan)</a:t>
+                        <a:t>(sample of 180 fixtures, sampling plan)</a:t>
                       </a:r>
                       <a:endParaRPr lang="en-US" sz="1000" dirty="0">
                         <a:latin typeface="Calibri" charset="0"/>
@@ -5992,7 +6040,7 @@
                           <a:ea typeface="Calibri" pitchFamily="34" charset="-122"/>
                           <a:cs typeface="Calibri" pitchFamily="34" charset="-120"/>
                         </a:rPr>
-                        <a:t>$2,000</a:t>
+                        <a:t>$1,500</a:t>
                       </a:r>
                       <a:endParaRPr lang="en-US" sz="1000" dirty="0">
                         <a:latin typeface="Calibri" charset="0"/>
@@ -6081,7 +6129,7 @@
                           <a:ea typeface="Calibri" pitchFamily="34" charset="-122"/>
                           <a:cs typeface="Calibri" pitchFamily="34" charset="-120"/>
                         </a:rPr>
-                        <a:t>(validates 157k kWh stipulation)</a:t>
+                        <a:t>(validates stipulated wattage</a:t>
                       </a:r>
                       <a:endParaRPr lang="en-US" sz="1000" dirty="0">
                         <a:latin typeface="Calibri" charset="0"/>
@@ -6270,479 +6318,6 @@
                 </a:tc>
               </a:tr>
               <a:tr h="640080">
-                <a:tc>
-                  <a:txBody>
-                    <a:bodyPr/>
-                    <a:lstStyle/>
-                    <a:p>
-                      <a:pPr indent="0" marL="0">
-                        <a:buNone/>
-                      </a:pPr>
-                      <a:r>
-                        <a:rPr lang="en-US" sz="1000" dirty="0">
-                          <a:solidFill>
-                            <a:srgbClr val="2D3748"/>
-                          </a:solidFill>
-                          <a:latin typeface="Calibri" pitchFamily="34" charset="0"/>
-                          <a:ea typeface="Calibri" pitchFamily="34" charset="-122"/>
-                          <a:cs typeface="Calibri" pitchFamily="34" charset="-120"/>
-                        </a:rPr>
-                        <a:t>Install 3 fan kW submeters</a:t>
-                      </a:r>
-                      <a:endParaRPr lang="en-US" sz="1000" dirty="0">
-                        <a:latin typeface="Calibri" charset="0"/>
-                        <a:ea typeface="Calibri" charset="0"/>
-                        <a:cs typeface="Calibri" charset="0"/>
-                      </a:endParaRPr>
-                    </a:p>
-                    <a:p>
-                      <a:pPr indent="0" marL="0">
-                        <a:buNone/>
-                      </a:pPr>
-                      <a:r>
-                        <a:rPr lang="en-US" sz="1000" dirty="0">
-                          <a:solidFill>
-                            <a:srgbClr val="2D3748"/>
-                          </a:solidFill>
-                          <a:latin typeface="Calibri" pitchFamily="34" charset="0"/>
-                          <a:ea typeface="Calibri" pitchFamily="34" charset="-122"/>
-                          <a:cs typeface="Calibri" pitchFamily="34" charset="-120"/>
-                        </a:rPr>
-                        <a:t>(AHU-1, AHU-2, AHU-3)</a:t>
-                      </a:r>
-                      <a:endParaRPr lang="en-US" sz="1000" dirty="0">
-                        <a:latin typeface="Calibri" charset="0"/>
-                        <a:ea typeface="Calibri" charset="0"/>
-                        <a:cs typeface="Calibri" charset="0"/>
-                      </a:endParaRPr>
-                    </a:p>
-                  </a:txBody>
-                  <a:tcPr marL="91440" marR="91440" marT="45720" marB="45720">
-                    <a:lnL w="6350" cap="flat" cmpd="sng" algn="ctr">
-                      <a:solidFill>
-                        <a:srgbClr val="DEE2E6"/>
-                      </a:solidFill>
-                      <a:prstDash val="solid"/>
-                      <a:round/>
-                      <a:headEnd type="none" w="med" len="med"/>
-                      <a:tailEnd type="none" w="med" len="med"/>
-                    </a:lnL>
-                    <a:lnR w="6350" cap="flat" cmpd="sng" algn="ctr">
-                      <a:solidFill>
-                        <a:srgbClr val="DEE2E6"/>
-                      </a:solidFill>
-                      <a:prstDash val="solid"/>
-                      <a:round/>
-                      <a:headEnd type="none" w="med" len="med"/>
-                      <a:tailEnd type="none" w="med" len="med"/>
-                    </a:lnR>
-                    <a:lnT w="6350" cap="flat" cmpd="sng" algn="ctr">
-                      <a:solidFill>
-                        <a:srgbClr val="DEE2E6"/>
-                      </a:solidFill>
-                      <a:prstDash val="solid"/>
-                      <a:round/>
-                      <a:headEnd type="none" w="med" len="med"/>
-                      <a:tailEnd type="none" w="med" len="med"/>
-                    </a:lnT>
-                    <a:lnB w="6350" cap="flat" cmpd="sng" algn="ctr">
-                      <a:solidFill>
-                        <a:srgbClr val="DEE2E6"/>
-                      </a:solidFill>
-                      <a:prstDash val="solid"/>
-                      <a:round/>
-                      <a:headEnd type="none" w="med" len="med"/>
-                      <a:tailEnd type="none" w="med" len="med"/>
-                    </a:lnB>
-                    <a:solidFill>
-                      <a:srgbClr val="F0F4F8"/>
-                    </a:solidFill>
-                  </a:tcPr>
-                </a:tc>
-                <a:tc>
-                  <a:txBody>
-                    <a:bodyPr/>
-                    <a:lstStyle/>
-                    <a:p>
-                      <a:pPr indent="0" marL="0">
-                        <a:buNone/>
-                      </a:pPr>
-                      <a:r>
-                        <a:rPr lang="en-US" sz="1000" dirty="0">
-                          <a:solidFill>
-                            <a:srgbClr val="2D3748"/>
-                          </a:solidFill>
-                          <a:latin typeface="Calibri" pitchFamily="34" charset="0"/>
-                          <a:ea typeface="Calibri" pitchFamily="34" charset="-122"/>
-                          <a:cs typeface="Calibri" pitchFamily="34" charset="-120"/>
-                        </a:rPr>
-                        <a:t>ECM-4</a:t>
-                      </a:r>
-                      <a:endParaRPr lang="en-US" sz="1000" dirty="0">
-                        <a:latin typeface="Calibri" charset="0"/>
-                        <a:ea typeface="Calibri" charset="0"/>
-                        <a:cs typeface="Calibri" charset="0"/>
-                      </a:endParaRPr>
-                    </a:p>
-                  </a:txBody>
-                  <a:tcPr marL="91440" marR="91440" marT="45720" marB="45720">
-                    <a:lnL w="6350" cap="flat" cmpd="sng" algn="ctr">
-                      <a:solidFill>
-                        <a:srgbClr val="DEE2E6"/>
-                      </a:solidFill>
-                      <a:prstDash val="solid"/>
-                      <a:round/>
-                      <a:headEnd type="none" w="med" len="med"/>
-                      <a:tailEnd type="none" w="med" len="med"/>
-                    </a:lnL>
-                    <a:lnR w="6350" cap="flat" cmpd="sng" algn="ctr">
-                      <a:solidFill>
-                        <a:srgbClr val="DEE2E6"/>
-                      </a:solidFill>
-                      <a:prstDash val="solid"/>
-                      <a:round/>
-                      <a:headEnd type="none" w="med" len="med"/>
-                      <a:tailEnd type="none" w="med" len="med"/>
-                    </a:lnR>
-                    <a:lnT w="6350" cap="flat" cmpd="sng" algn="ctr">
-                      <a:solidFill>
-                        <a:srgbClr val="DEE2E6"/>
-                      </a:solidFill>
-                      <a:prstDash val="solid"/>
-                      <a:round/>
-                      <a:headEnd type="none" w="med" len="med"/>
-                      <a:tailEnd type="none" w="med" len="med"/>
-                    </a:lnT>
-                    <a:lnB w="6350" cap="flat" cmpd="sng" algn="ctr">
-                      <a:solidFill>
-                        <a:srgbClr val="DEE2E6"/>
-                      </a:solidFill>
-                      <a:prstDash val="solid"/>
-                      <a:round/>
-                      <a:headEnd type="none" w="med" len="med"/>
-                      <a:tailEnd type="none" w="med" len="med"/>
-                    </a:lnB>
-                    <a:solidFill>
-                      <a:srgbClr val="F0F4F8"/>
-                    </a:solidFill>
-                  </a:tcPr>
-                </a:tc>
-                <a:tc>
-                  <a:txBody>
-                    <a:bodyPr/>
-                    <a:lstStyle/>
-                    <a:p>
-                      <a:pPr indent="0" marL="0">
-                        <a:buNone/>
-                      </a:pPr>
-                      <a:r>
-                        <a:rPr lang="en-US" sz="1000" dirty="0">
-                          <a:solidFill>
-                            <a:srgbClr val="2D3748"/>
-                          </a:solidFill>
-                          <a:latin typeface="Calibri" pitchFamily="34" charset="0"/>
-                          <a:ea typeface="Calibri" pitchFamily="34" charset="-122"/>
-                          <a:cs typeface="Calibri" pitchFamily="34" charset="-120"/>
-                        </a:rPr>
-                        <a:t>$8,000</a:t>
-                      </a:r>
-                      <a:endParaRPr lang="en-US" sz="1000" dirty="0">
-                        <a:latin typeface="Calibri" charset="0"/>
-                        <a:ea typeface="Calibri" charset="0"/>
-                        <a:cs typeface="Calibri" charset="0"/>
-                      </a:endParaRPr>
-                    </a:p>
-                  </a:txBody>
-                  <a:tcPr marL="91440" marR="91440" marT="45720" marB="45720">
-                    <a:lnL w="6350" cap="flat" cmpd="sng" algn="ctr">
-                      <a:solidFill>
-                        <a:srgbClr val="DEE2E6"/>
-                      </a:solidFill>
-                      <a:prstDash val="solid"/>
-                      <a:round/>
-                      <a:headEnd type="none" w="med" len="med"/>
-                      <a:tailEnd type="none" w="med" len="med"/>
-                    </a:lnL>
-                    <a:lnR w="6350" cap="flat" cmpd="sng" algn="ctr">
-                      <a:solidFill>
-                        <a:srgbClr val="DEE2E6"/>
-                      </a:solidFill>
-                      <a:prstDash val="solid"/>
-                      <a:round/>
-                      <a:headEnd type="none" w="med" len="med"/>
-                      <a:tailEnd type="none" w="med" len="med"/>
-                    </a:lnR>
-                    <a:lnT w="6350" cap="flat" cmpd="sng" algn="ctr">
-                      <a:solidFill>
-                        <a:srgbClr val="DEE2E6"/>
-                      </a:solidFill>
-                      <a:prstDash val="solid"/>
-                      <a:round/>
-                      <a:headEnd type="none" w="med" len="med"/>
-                      <a:tailEnd type="none" w="med" len="med"/>
-                    </a:lnT>
-                    <a:lnB w="6350" cap="flat" cmpd="sng" algn="ctr">
-                      <a:solidFill>
-                        <a:srgbClr val="DEE2E6"/>
-                      </a:solidFill>
-                      <a:prstDash val="solid"/>
-                      <a:round/>
-                      <a:headEnd type="none" w="med" len="med"/>
-                      <a:tailEnd type="none" w="med" len="med"/>
-                    </a:lnB>
-                    <a:solidFill>
-                      <a:srgbClr val="F0F4F8"/>
-                    </a:solidFill>
-                  </a:tcPr>
-                </a:tc>
-                <a:tc>
-                  <a:txBody>
-                    <a:bodyPr/>
-                    <a:lstStyle/>
-                    <a:p>
-                      <a:pPr indent="0" marL="0">
-                        <a:buNone/>
-                      </a:pPr>
-                      <a:r>
-                        <a:rPr lang="en-US" sz="1000" dirty="0">
-                          <a:solidFill>
-                            <a:srgbClr val="2D3748"/>
-                          </a:solidFill>
-                          <a:latin typeface="Calibri" pitchFamily="34" charset="0"/>
-                          <a:ea typeface="Calibri" pitchFamily="34" charset="-122"/>
-                          <a:cs typeface="Calibri" pitchFamily="34" charset="-120"/>
-                        </a:rPr>
-                        <a:t>High</a:t>
-                      </a:r>
-                      <a:endParaRPr lang="en-US" sz="1000" dirty="0">
-                        <a:latin typeface="Calibri" charset="0"/>
-                        <a:ea typeface="Calibri" charset="0"/>
-                        <a:cs typeface="Calibri" charset="0"/>
-                      </a:endParaRPr>
-                    </a:p>
-                    <a:p>
-                      <a:pPr indent="0" marL="0">
-                        <a:buNone/>
-                      </a:pPr>
-                      <a:r>
-                        <a:rPr lang="en-US" sz="1000" dirty="0">
-                          <a:solidFill>
-                            <a:srgbClr val="2D3748"/>
-                          </a:solidFill>
-                          <a:latin typeface="Calibri" pitchFamily="34" charset="0"/>
-                          <a:ea typeface="Calibri" pitchFamily="34" charset="-122"/>
-                          <a:cs typeface="Calibri" pitchFamily="34" charset="-120"/>
-                        </a:rPr>
-                        <a:t>(continuous verification of</a:t>
-                      </a:r>
-                      <a:endParaRPr lang="en-US" sz="1000" dirty="0">
-                        <a:latin typeface="Calibri" charset="0"/>
-                        <a:ea typeface="Calibri" charset="0"/>
-                        <a:cs typeface="Calibri" charset="0"/>
-                      </a:endParaRPr>
-                    </a:p>
-                    <a:p>
-                      <a:pPr indent="0" marL="0">
-                        <a:buNone/>
-                      </a:pPr>
-                      <a:r>
-                        <a:rPr lang="en-US" sz="1000" dirty="0">
-                          <a:solidFill>
-                            <a:srgbClr val="2D3748"/>
-                          </a:solidFill>
-                          <a:latin typeface="Calibri" pitchFamily="34" charset="0"/>
-                          <a:ea typeface="Calibri" pitchFamily="34" charset="-122"/>
-                          <a:cs typeface="Calibri" pitchFamily="34" charset="-120"/>
-                        </a:rPr>
-                        <a:t>variable-load savings)</a:t>
-                      </a:r>
-                      <a:endParaRPr lang="en-US" sz="1000" dirty="0">
-                        <a:latin typeface="Calibri" charset="0"/>
-                        <a:ea typeface="Calibri" charset="0"/>
-                        <a:cs typeface="Calibri" charset="0"/>
-                      </a:endParaRPr>
-                    </a:p>
-                  </a:txBody>
-                  <a:tcPr marL="91440" marR="91440" marT="45720" marB="45720">
-                    <a:lnL w="6350" cap="flat" cmpd="sng" algn="ctr">
-                      <a:solidFill>
-                        <a:srgbClr val="DEE2E6"/>
-                      </a:solidFill>
-                      <a:prstDash val="solid"/>
-                      <a:round/>
-                      <a:headEnd type="none" w="med" len="med"/>
-                      <a:tailEnd type="none" w="med" len="med"/>
-                    </a:lnL>
-                    <a:lnR w="6350" cap="flat" cmpd="sng" algn="ctr">
-                      <a:solidFill>
-                        <a:srgbClr val="DEE2E6"/>
-                      </a:solidFill>
-                      <a:prstDash val="solid"/>
-                      <a:round/>
-                      <a:headEnd type="none" w="med" len="med"/>
-                      <a:tailEnd type="none" w="med" len="med"/>
-                    </a:lnR>
-                    <a:lnT w="6350" cap="flat" cmpd="sng" algn="ctr">
-                      <a:solidFill>
-                        <a:srgbClr val="DEE2E6"/>
-                      </a:solidFill>
-                      <a:prstDash val="solid"/>
-                      <a:round/>
-                      <a:headEnd type="none" w="med" len="med"/>
-                      <a:tailEnd type="none" w="med" len="med"/>
-                    </a:lnT>
-                    <a:lnB w="6350" cap="flat" cmpd="sng" algn="ctr">
-                      <a:solidFill>
-                        <a:srgbClr val="DEE2E6"/>
-                      </a:solidFill>
-                      <a:prstDash val="solid"/>
-                      <a:round/>
-                      <a:headEnd type="none" w="med" len="med"/>
-                      <a:tailEnd type="none" w="med" len="med"/>
-                    </a:lnB>
-                    <a:solidFill>
-                      <a:srgbClr val="F0F4F8"/>
-                    </a:solidFill>
-                  </a:tcPr>
-                </a:tc>
-                <a:tc>
-                  <a:txBody>
-                    <a:bodyPr/>
-                    <a:lstStyle/>
-                    <a:p>
-                      <a:pPr indent="0" marL="0">
-                        <a:buNone/>
-                      </a:pPr>
-                      <a:r>
-                        <a:rPr lang="en-US" sz="1000" b="1" dirty="0">
-                          <a:solidFill>
-                            <a:srgbClr val="2F855A"/>
-                          </a:solidFill>
-                          <a:latin typeface="Calibri" pitchFamily="34" charset="0"/>
-                          <a:ea typeface="Calibri" pitchFamily="34" charset="-122"/>
-                          <a:cs typeface="Calibri" pitchFamily="34" charset="-120"/>
-                        </a:rPr>
-                        <a:t>★★★★</a:t>
-                      </a:r>
-                      <a:endParaRPr lang="en-US" sz="1000" dirty="0">
-                        <a:latin typeface="Calibri" charset="0"/>
-                        <a:ea typeface="Calibri" charset="0"/>
-                        <a:cs typeface="Calibri" charset="0"/>
-                      </a:endParaRPr>
-                    </a:p>
-                  </a:txBody>
-                  <a:tcPr marL="91440" marR="91440" marT="45720" marB="45720">
-                    <a:lnL w="6350" cap="flat" cmpd="sng" algn="ctr">
-                      <a:solidFill>
-                        <a:srgbClr val="DEE2E6"/>
-                      </a:solidFill>
-                      <a:prstDash val="solid"/>
-                      <a:round/>
-                      <a:headEnd type="none" w="med" len="med"/>
-                      <a:tailEnd type="none" w="med" len="med"/>
-                    </a:lnL>
-                    <a:lnR w="6350" cap="flat" cmpd="sng" algn="ctr">
-                      <a:solidFill>
-                        <a:srgbClr val="DEE2E6"/>
-                      </a:solidFill>
-                      <a:prstDash val="solid"/>
-                      <a:round/>
-                      <a:headEnd type="none" w="med" len="med"/>
-                      <a:tailEnd type="none" w="med" len="med"/>
-                    </a:lnR>
-                    <a:lnT w="6350" cap="flat" cmpd="sng" algn="ctr">
-                      <a:solidFill>
-                        <a:srgbClr val="DEE2E6"/>
-                      </a:solidFill>
-                      <a:prstDash val="solid"/>
-                      <a:round/>
-                      <a:headEnd type="none" w="med" len="med"/>
-                      <a:tailEnd type="none" w="med" len="med"/>
-                    </a:lnT>
-                    <a:lnB w="6350" cap="flat" cmpd="sng" algn="ctr">
-                      <a:solidFill>
-                        <a:srgbClr val="DEE2E6"/>
-                      </a:solidFill>
-                      <a:prstDash val="solid"/>
-                      <a:round/>
-                      <a:headEnd type="none" w="med" len="med"/>
-                      <a:tailEnd type="none" w="med" len="med"/>
-                    </a:lnB>
-                    <a:solidFill>
-                      <a:srgbClr val="F0F4F8"/>
-                    </a:solidFill>
-                  </a:tcPr>
-                </a:tc>
-                <a:tc>
-                  <a:txBody>
-                    <a:bodyPr/>
-                    <a:lstStyle/>
-                    <a:p>
-                      <a:pPr indent="0" marL="0">
-                        <a:buNone/>
-                      </a:pPr>
-                      <a:r>
-                        <a:rPr lang="en-US" sz="1000" b="1" dirty="0">
-                          <a:solidFill>
-                            <a:srgbClr val="2F855A"/>
-                          </a:solidFill>
-                          <a:latin typeface="Calibri" pitchFamily="34" charset="0"/>
-                          <a:ea typeface="Calibri" pitchFamily="34" charset="-122"/>
-                          <a:cs typeface="Calibri" pitchFamily="34" charset="-120"/>
-                        </a:rPr>
-                        <a:t>#2</a:t>
-                      </a:r>
-                      <a:endParaRPr lang="en-US" sz="1000" dirty="0">
-                        <a:latin typeface="Calibri" charset="0"/>
-                        <a:ea typeface="Calibri" charset="0"/>
-                        <a:cs typeface="Calibri" charset="0"/>
-                      </a:endParaRPr>
-                    </a:p>
-                  </a:txBody>
-                  <a:tcPr marL="91440" marR="91440" marT="45720" marB="45720">
-                    <a:lnL w="6350" cap="flat" cmpd="sng" algn="ctr">
-                      <a:solidFill>
-                        <a:srgbClr val="DEE2E6"/>
-                      </a:solidFill>
-                      <a:prstDash val="solid"/>
-                      <a:round/>
-                      <a:headEnd type="none" w="med" len="med"/>
-                      <a:tailEnd type="none" w="med" len="med"/>
-                    </a:lnL>
-                    <a:lnR w="6350" cap="flat" cmpd="sng" algn="ctr">
-                      <a:solidFill>
-                        <a:srgbClr val="DEE2E6"/>
-                      </a:solidFill>
-                      <a:prstDash val="solid"/>
-                      <a:round/>
-                      <a:headEnd type="none" w="med" len="med"/>
-                      <a:tailEnd type="none" w="med" len="med"/>
-                    </a:lnR>
-                    <a:lnT w="6350" cap="flat" cmpd="sng" algn="ctr">
-                      <a:solidFill>
-                        <a:srgbClr val="DEE2E6"/>
-                      </a:solidFill>
-                      <a:prstDash val="solid"/>
-                      <a:round/>
-                      <a:headEnd type="none" w="med" len="med"/>
-                      <a:tailEnd type="none" w="med" len="med"/>
-                    </a:lnT>
-                    <a:lnB w="6350" cap="flat" cmpd="sng" algn="ctr">
-                      <a:solidFill>
-                        <a:srgbClr val="DEE2E6"/>
-                      </a:solidFill>
-                      <a:prstDash val="solid"/>
-                      <a:round/>
-                      <a:headEnd type="none" w="med" len="med"/>
-                      <a:tailEnd type="none" w="med" len="med"/>
-                    </a:lnB>
-                    <a:solidFill>
-                      <a:srgbClr val="F0F4F8"/>
-                    </a:solidFill>
-                  </a:tcPr>
-                </a:tc>
-              </a:tr>
-              <a:tr h="548640">
                 <a:tc>
                   <a:txBody>
                     <a:bodyPr/>
@@ -6828,7 +6403,7 @@
                       <a:tailEnd type="none" w="med" len="med"/>
                     </a:lnB>
                     <a:solidFill>
-                      <a:srgbClr val="FFFFFF"/>
+                      <a:srgbClr val="F0F4F8"/>
                     </a:solidFill>
                   </a:tcPr>
                 </a:tc>
@@ -6849,7 +6424,7 @@
                           <a:ea typeface="Calibri" pitchFamily="34" charset="-122"/>
                           <a:cs typeface="Calibri" pitchFamily="34" charset="-120"/>
                         </a:rPr>
-                        <a:t>ECM-2,3</a:t>
+                        <a:t>ECM-2</a:t>
                       </a:r>
                       <a:endParaRPr lang="en-US" sz="1000" dirty="0">
                         <a:latin typeface="Calibri" charset="0"/>
@@ -6896,7 +6471,7 @@
                       <a:tailEnd type="none" w="med" len="med"/>
                     </a:lnB>
                     <a:solidFill>
-                      <a:srgbClr val="FFFFFF"/>
+                      <a:srgbClr val="F0F4F8"/>
                     </a:solidFill>
                   </a:tcPr>
                 </a:tc>
@@ -6917,7 +6492,7 @@
                           <a:ea typeface="Calibri" pitchFamily="34" charset="-122"/>
                           <a:cs typeface="Calibri" pitchFamily="34" charset="-120"/>
                         </a:rPr>
-                        <a:t>$3,000</a:t>
+                        <a:t>$2,000</a:t>
                       </a:r>
                       <a:endParaRPr lang="en-US" sz="1000" dirty="0">
                         <a:latin typeface="Calibri" charset="0"/>
@@ -6964,7 +6539,7 @@
                       <a:tailEnd type="none" w="med" len="med"/>
                     </a:lnB>
                     <a:solidFill>
-                      <a:srgbClr val="FFFFFF"/>
+                      <a:srgbClr val="F0F4F8"/>
                     </a:solidFill>
                   </a:tcPr>
                 </a:tc>
@@ -6985,7 +6560,7 @@
                           <a:ea typeface="Calibri" pitchFamily="34" charset="-122"/>
                           <a:cs typeface="Calibri" pitchFamily="34" charset="-120"/>
                         </a:rPr>
-                        <a:t>Medium</a:t>
+                        <a:t>High</a:t>
                       </a:r>
                       <a:endParaRPr lang="en-US" sz="1000" dirty="0">
                         <a:latin typeface="Calibri" charset="0"/>
@@ -7074,6 +6649,479 @@
                       <a:tailEnd type="none" w="med" len="med"/>
                     </a:lnB>
                     <a:solidFill>
+                      <a:srgbClr val="F0F4F8"/>
+                    </a:solidFill>
+                  </a:tcPr>
+                </a:tc>
+                <a:tc>
+                  <a:txBody>
+                    <a:bodyPr/>
+                    <a:lstStyle/>
+                    <a:p>
+                      <a:pPr indent="0" marL="0">
+                        <a:buNone/>
+                      </a:pPr>
+                      <a:r>
+                        <a:rPr lang="en-US" sz="1000" b="1" dirty="0">
+                          <a:solidFill>
+                            <a:srgbClr val="2F855A"/>
+                          </a:solidFill>
+                          <a:latin typeface="Calibri" pitchFamily="34" charset="0"/>
+                          <a:ea typeface="Calibri" pitchFamily="34" charset="-122"/>
+                          <a:cs typeface="Calibri" pitchFamily="34" charset="-120"/>
+                        </a:rPr>
+                        <a:t>★★★</a:t>
+                      </a:r>
+                      <a:endParaRPr lang="en-US" sz="1000" dirty="0">
+                        <a:latin typeface="Calibri" charset="0"/>
+                        <a:ea typeface="Calibri" charset="0"/>
+                        <a:cs typeface="Calibri" charset="0"/>
+                      </a:endParaRPr>
+                    </a:p>
+                  </a:txBody>
+                  <a:tcPr marL="91440" marR="91440" marT="45720" marB="45720">
+                    <a:lnL w="6350" cap="flat" cmpd="sng" algn="ctr">
+                      <a:solidFill>
+                        <a:srgbClr val="DEE2E6"/>
+                      </a:solidFill>
+                      <a:prstDash val="solid"/>
+                      <a:round/>
+                      <a:headEnd type="none" w="med" len="med"/>
+                      <a:tailEnd type="none" w="med" len="med"/>
+                    </a:lnL>
+                    <a:lnR w="6350" cap="flat" cmpd="sng" algn="ctr">
+                      <a:solidFill>
+                        <a:srgbClr val="DEE2E6"/>
+                      </a:solidFill>
+                      <a:prstDash val="solid"/>
+                      <a:round/>
+                      <a:headEnd type="none" w="med" len="med"/>
+                      <a:tailEnd type="none" w="med" len="med"/>
+                    </a:lnR>
+                    <a:lnT w="6350" cap="flat" cmpd="sng" algn="ctr">
+                      <a:solidFill>
+                        <a:srgbClr val="DEE2E6"/>
+                      </a:solidFill>
+                      <a:prstDash val="solid"/>
+                      <a:round/>
+                      <a:headEnd type="none" w="med" len="med"/>
+                      <a:tailEnd type="none" w="med" len="med"/>
+                    </a:lnT>
+                    <a:lnB w="6350" cap="flat" cmpd="sng" algn="ctr">
+                      <a:solidFill>
+                        <a:srgbClr val="DEE2E6"/>
+                      </a:solidFill>
+                      <a:prstDash val="solid"/>
+                      <a:round/>
+                      <a:headEnd type="none" w="med" len="med"/>
+                      <a:tailEnd type="none" w="med" len="med"/>
+                    </a:lnB>
+                    <a:solidFill>
+                      <a:srgbClr val="F0F4F8"/>
+                    </a:solidFill>
+                  </a:tcPr>
+                </a:tc>
+                <a:tc>
+                  <a:txBody>
+                    <a:bodyPr/>
+                    <a:lstStyle/>
+                    <a:p>
+                      <a:pPr indent="0" marL="0">
+                        <a:buNone/>
+                      </a:pPr>
+                      <a:r>
+                        <a:rPr lang="en-US" sz="1000" b="1" dirty="0">
+                          <a:solidFill>
+                            <a:srgbClr val="2F855A"/>
+                          </a:solidFill>
+                          <a:latin typeface="Calibri" pitchFamily="34" charset="0"/>
+                          <a:ea typeface="Calibri" pitchFamily="34" charset="-122"/>
+                          <a:cs typeface="Calibri" pitchFamily="34" charset="-120"/>
+                        </a:rPr>
+                        <a:t>#2</a:t>
+                      </a:r>
+                      <a:endParaRPr lang="en-US" sz="1000" dirty="0">
+                        <a:latin typeface="Calibri" charset="0"/>
+                        <a:ea typeface="Calibri" charset="0"/>
+                        <a:cs typeface="Calibri" charset="0"/>
+                      </a:endParaRPr>
+                    </a:p>
+                  </a:txBody>
+                  <a:tcPr marL="91440" marR="91440" marT="45720" marB="45720">
+                    <a:lnL w="6350" cap="flat" cmpd="sng" algn="ctr">
+                      <a:solidFill>
+                        <a:srgbClr val="DEE2E6"/>
+                      </a:solidFill>
+                      <a:prstDash val="solid"/>
+                      <a:round/>
+                      <a:headEnd type="none" w="med" len="med"/>
+                      <a:tailEnd type="none" w="med" len="med"/>
+                    </a:lnL>
+                    <a:lnR w="6350" cap="flat" cmpd="sng" algn="ctr">
+                      <a:solidFill>
+                        <a:srgbClr val="DEE2E6"/>
+                      </a:solidFill>
+                      <a:prstDash val="solid"/>
+                      <a:round/>
+                      <a:headEnd type="none" w="med" len="med"/>
+                      <a:tailEnd type="none" w="med" len="med"/>
+                    </a:lnR>
+                    <a:lnT w="6350" cap="flat" cmpd="sng" algn="ctr">
+                      <a:solidFill>
+                        <a:srgbClr val="DEE2E6"/>
+                      </a:solidFill>
+                      <a:prstDash val="solid"/>
+                      <a:round/>
+                      <a:headEnd type="none" w="med" len="med"/>
+                      <a:tailEnd type="none" w="med" len="med"/>
+                    </a:lnT>
+                    <a:lnB w="6350" cap="flat" cmpd="sng" algn="ctr">
+                      <a:solidFill>
+                        <a:srgbClr val="DEE2E6"/>
+                      </a:solidFill>
+                      <a:prstDash val="solid"/>
+                      <a:round/>
+                      <a:headEnd type="none" w="med" len="med"/>
+                      <a:tailEnd type="none" w="med" len="med"/>
+                    </a:lnB>
+                    <a:solidFill>
+                      <a:srgbClr val="F0F4F8"/>
+                    </a:solidFill>
+                  </a:tcPr>
+                </a:tc>
+              </a:tr>
+              <a:tr h="548640">
+                <a:tc>
+                  <a:txBody>
+                    <a:bodyPr/>
+                    <a:lstStyle/>
+                    <a:p>
+                      <a:pPr indent="0" marL="0">
+                        <a:buNone/>
+                      </a:pPr>
+                      <a:r>
+                        <a:rPr lang="en-US" sz="1000" dirty="0">
+                          <a:solidFill>
+                            <a:srgbClr val="2D3748"/>
+                          </a:solidFill>
+                          <a:latin typeface="Calibri" pitchFamily="34" charset="0"/>
+                          <a:ea typeface="Calibri" pitchFamily="34" charset="-122"/>
+                          <a:cs typeface="Calibri" pitchFamily="34" charset="-120"/>
+                        </a:rPr>
+                        <a:t>Stipulate operating hours</a:t>
+                      </a:r>
+                      <a:endParaRPr lang="en-US" sz="1000" dirty="0">
+                        <a:latin typeface="Calibri" charset="0"/>
+                        <a:ea typeface="Calibri" charset="0"/>
+                        <a:cs typeface="Calibri" charset="0"/>
+                      </a:endParaRPr>
+                    </a:p>
+                    <a:p>
+                      <a:pPr indent="0" marL="0">
+                        <a:buNone/>
+                      </a:pPr>
+                      <a:r>
+                        <a:rPr lang="en-US" sz="1000" dirty="0">
+                          <a:solidFill>
+                            <a:srgbClr val="2D3748"/>
+                          </a:solidFill>
+                          <a:latin typeface="Calibri" pitchFamily="34" charset="0"/>
+                          <a:ea typeface="Calibri" pitchFamily="34" charset="-122"/>
+                          <a:cs typeface="Calibri" pitchFamily="34" charset="-120"/>
+                        </a:rPr>
+                        <a:t>(document &amp; defend assumption)</a:t>
+                      </a:r>
+                      <a:endParaRPr lang="en-US" sz="1000" dirty="0">
+                        <a:latin typeface="Calibri" charset="0"/>
+                        <a:ea typeface="Calibri" charset="0"/>
+                        <a:cs typeface="Calibri" charset="0"/>
+                      </a:endParaRPr>
+                    </a:p>
+                  </a:txBody>
+                  <a:tcPr marL="91440" marR="91440" marT="45720" marB="45720">
+                    <a:lnL w="6350" cap="flat" cmpd="sng" algn="ctr">
+                      <a:solidFill>
+                        <a:srgbClr val="DEE2E6"/>
+                      </a:solidFill>
+                      <a:prstDash val="solid"/>
+                      <a:round/>
+                      <a:headEnd type="none" w="med" len="med"/>
+                      <a:tailEnd type="none" w="med" len="med"/>
+                    </a:lnL>
+                    <a:lnR w="6350" cap="flat" cmpd="sng" algn="ctr">
+                      <a:solidFill>
+                        <a:srgbClr val="DEE2E6"/>
+                      </a:solidFill>
+                      <a:prstDash val="solid"/>
+                      <a:round/>
+                      <a:headEnd type="none" w="med" len="med"/>
+                      <a:tailEnd type="none" w="med" len="med"/>
+                    </a:lnR>
+                    <a:lnT w="6350" cap="flat" cmpd="sng" algn="ctr">
+                      <a:solidFill>
+                        <a:srgbClr val="DEE2E6"/>
+                      </a:solidFill>
+                      <a:prstDash val="solid"/>
+                      <a:round/>
+                      <a:headEnd type="none" w="med" len="med"/>
+                      <a:tailEnd type="none" w="med" len="med"/>
+                    </a:lnT>
+                    <a:lnB w="6350" cap="flat" cmpd="sng" algn="ctr">
+                      <a:solidFill>
+                        <a:srgbClr val="DEE2E6"/>
+                      </a:solidFill>
+                      <a:prstDash val="solid"/>
+                      <a:round/>
+                      <a:headEnd type="none" w="med" len="med"/>
+                      <a:tailEnd type="none" w="med" len="med"/>
+                    </a:lnB>
+                    <a:solidFill>
+                      <a:srgbClr val="FFFFFF"/>
+                    </a:solidFill>
+                  </a:tcPr>
+                </a:tc>
+                <a:tc>
+                  <a:txBody>
+                    <a:bodyPr/>
+                    <a:lstStyle/>
+                    <a:p>
+                      <a:pPr indent="0" marL="0">
+                        <a:buNone/>
+                      </a:pPr>
+                      <a:r>
+                        <a:rPr lang="en-US" sz="1000" dirty="0">
+                          <a:solidFill>
+                            <a:srgbClr val="2D3748"/>
+                          </a:solidFill>
+                          <a:latin typeface="Calibri" pitchFamily="34" charset="0"/>
+                          <a:ea typeface="Calibri" pitchFamily="34" charset="-122"/>
+                          <a:cs typeface="Calibri" pitchFamily="34" charset="-120"/>
+                        </a:rPr>
+                        <a:t>ECM-1</a:t>
+                      </a:r>
+                      <a:endParaRPr lang="en-US" sz="1000" dirty="0">
+                        <a:latin typeface="Calibri" charset="0"/>
+                        <a:ea typeface="Calibri" charset="0"/>
+                        <a:cs typeface="Calibri" charset="0"/>
+                      </a:endParaRPr>
+                    </a:p>
+                  </a:txBody>
+                  <a:tcPr marL="91440" marR="91440" marT="45720" marB="45720">
+                    <a:lnL w="6350" cap="flat" cmpd="sng" algn="ctr">
+                      <a:solidFill>
+                        <a:srgbClr val="DEE2E6"/>
+                      </a:solidFill>
+                      <a:prstDash val="solid"/>
+                      <a:round/>
+                      <a:headEnd type="none" w="med" len="med"/>
+                      <a:tailEnd type="none" w="med" len="med"/>
+                    </a:lnL>
+                    <a:lnR w="6350" cap="flat" cmpd="sng" algn="ctr">
+                      <a:solidFill>
+                        <a:srgbClr val="DEE2E6"/>
+                      </a:solidFill>
+                      <a:prstDash val="solid"/>
+                      <a:round/>
+                      <a:headEnd type="none" w="med" len="med"/>
+                      <a:tailEnd type="none" w="med" len="med"/>
+                    </a:lnR>
+                    <a:lnT w="6350" cap="flat" cmpd="sng" algn="ctr">
+                      <a:solidFill>
+                        <a:srgbClr val="DEE2E6"/>
+                      </a:solidFill>
+                      <a:prstDash val="solid"/>
+                      <a:round/>
+                      <a:headEnd type="none" w="med" len="med"/>
+                      <a:tailEnd type="none" w="med" len="med"/>
+                    </a:lnT>
+                    <a:lnB w="6350" cap="flat" cmpd="sng" algn="ctr">
+                      <a:solidFill>
+                        <a:srgbClr val="DEE2E6"/>
+                      </a:solidFill>
+                      <a:prstDash val="solid"/>
+                      <a:round/>
+                      <a:headEnd type="none" w="med" len="med"/>
+                      <a:tailEnd type="none" w="med" len="med"/>
+                    </a:lnB>
+                    <a:solidFill>
+                      <a:srgbClr val="FFFFFF"/>
+                    </a:solidFill>
+                  </a:tcPr>
+                </a:tc>
+                <a:tc>
+                  <a:txBody>
+                    <a:bodyPr/>
+                    <a:lstStyle/>
+                    <a:p>
+                      <a:pPr indent="0" marL="0">
+                        <a:buNone/>
+                      </a:pPr>
+                      <a:r>
+                        <a:rPr lang="en-US" sz="1000" dirty="0">
+                          <a:solidFill>
+                            <a:srgbClr val="2D3748"/>
+                          </a:solidFill>
+                          <a:latin typeface="Calibri" pitchFamily="34" charset="0"/>
+                          <a:ea typeface="Calibri" pitchFamily="34" charset="-122"/>
+                          <a:cs typeface="Calibri" pitchFamily="34" charset="-120"/>
+                        </a:rPr>
+                        <a:t>$500</a:t>
+                      </a:r>
+                      <a:endParaRPr lang="en-US" sz="1000" dirty="0">
+                        <a:latin typeface="Calibri" charset="0"/>
+                        <a:ea typeface="Calibri" charset="0"/>
+                        <a:cs typeface="Calibri" charset="0"/>
+                      </a:endParaRPr>
+                    </a:p>
+                  </a:txBody>
+                  <a:tcPr marL="91440" marR="91440" marT="45720" marB="45720">
+                    <a:lnL w="6350" cap="flat" cmpd="sng" algn="ctr">
+                      <a:solidFill>
+                        <a:srgbClr val="DEE2E6"/>
+                      </a:solidFill>
+                      <a:prstDash val="solid"/>
+                      <a:round/>
+                      <a:headEnd type="none" w="med" len="med"/>
+                      <a:tailEnd type="none" w="med" len="med"/>
+                    </a:lnL>
+                    <a:lnR w="6350" cap="flat" cmpd="sng" algn="ctr">
+                      <a:solidFill>
+                        <a:srgbClr val="DEE2E6"/>
+                      </a:solidFill>
+                      <a:prstDash val="solid"/>
+                      <a:round/>
+                      <a:headEnd type="none" w="med" len="med"/>
+                      <a:tailEnd type="none" w="med" len="med"/>
+                    </a:lnR>
+                    <a:lnT w="6350" cap="flat" cmpd="sng" algn="ctr">
+                      <a:solidFill>
+                        <a:srgbClr val="DEE2E6"/>
+                      </a:solidFill>
+                      <a:prstDash val="solid"/>
+                      <a:round/>
+                      <a:headEnd type="none" w="med" len="med"/>
+                      <a:tailEnd type="none" w="med" len="med"/>
+                    </a:lnT>
+                    <a:lnB w="6350" cap="flat" cmpd="sng" algn="ctr">
+                      <a:solidFill>
+                        <a:srgbClr val="DEE2E6"/>
+                      </a:solidFill>
+                      <a:prstDash val="solid"/>
+                      <a:round/>
+                      <a:headEnd type="none" w="med" len="med"/>
+                      <a:tailEnd type="none" w="med" len="med"/>
+                    </a:lnB>
+                    <a:solidFill>
+                      <a:srgbClr val="FFFFFF"/>
+                    </a:solidFill>
+                  </a:tcPr>
+                </a:tc>
+                <a:tc>
+                  <a:txBody>
+                    <a:bodyPr/>
+                    <a:lstStyle/>
+                    <a:p>
+                      <a:pPr indent="0" marL="0">
+                        <a:buNone/>
+                      </a:pPr>
+                      <a:r>
+                        <a:rPr lang="en-US" sz="1000" dirty="0">
+                          <a:solidFill>
+                            <a:srgbClr val="2D3748"/>
+                          </a:solidFill>
+                          <a:latin typeface="Calibri" pitchFamily="34" charset="0"/>
+                          <a:ea typeface="Calibri" pitchFamily="34" charset="-122"/>
+                          <a:cs typeface="Calibri" pitchFamily="34" charset="-120"/>
+                        </a:rPr>
+                        <a:t>Medium</a:t>
+                      </a:r>
+                      <a:endParaRPr lang="en-US" sz="1000" dirty="0">
+                        <a:latin typeface="Calibri" charset="0"/>
+                        <a:ea typeface="Calibri" charset="0"/>
+                        <a:cs typeface="Calibri" charset="0"/>
+                      </a:endParaRPr>
+                    </a:p>
+                    <a:p>
+                      <a:pPr indent="0" marL="0">
+                        <a:buNone/>
+                      </a:pPr>
+                      <a:r>
+                        <a:rPr lang="en-US" sz="1000" dirty="0">
+                          <a:solidFill>
+                            <a:srgbClr val="2D3748"/>
+                          </a:solidFill>
+                          <a:latin typeface="Calibri" pitchFamily="34" charset="0"/>
+                          <a:ea typeface="Calibri" pitchFamily="34" charset="-122"/>
+                          <a:cs typeface="Calibri" pitchFamily="34" charset="-120"/>
+                        </a:rPr>
+                        <a:t>(stable parameter;</a:t>
+                      </a:r>
+                      <a:endParaRPr lang="en-US" sz="1000" dirty="0">
+                        <a:latin typeface="Calibri" charset="0"/>
+                        <a:ea typeface="Calibri" charset="0"/>
+                        <a:cs typeface="Calibri" charset="0"/>
+                      </a:endParaRPr>
+                    </a:p>
+                    <a:p>
+                      <a:pPr indent="0" marL="0">
+                        <a:buNone/>
+                      </a:pPr>
+                      <a:r>
+                        <a:rPr lang="en-US" sz="1000" dirty="0">
+                          <a:solidFill>
+                            <a:srgbClr val="2D3748"/>
+                          </a:solidFill>
+                          <a:latin typeface="Calibri" pitchFamily="34" charset="0"/>
+                          <a:ea typeface="Calibri" pitchFamily="34" charset="-122"/>
+                          <a:cs typeface="Calibri" pitchFamily="34" charset="-120"/>
+                        </a:rPr>
+                        <a:t>defensible with timeclock data)</a:t>
+                      </a:r>
+                      <a:endParaRPr lang="en-US" sz="1000" dirty="0">
+                        <a:latin typeface="Calibri" charset="0"/>
+                        <a:ea typeface="Calibri" charset="0"/>
+                        <a:cs typeface="Calibri" charset="0"/>
+                      </a:endParaRPr>
+                    </a:p>
+                  </a:txBody>
+                  <a:tcPr marL="91440" marR="91440" marT="45720" marB="45720">
+                    <a:lnL w="6350" cap="flat" cmpd="sng" algn="ctr">
+                      <a:solidFill>
+                        <a:srgbClr val="DEE2E6"/>
+                      </a:solidFill>
+                      <a:prstDash val="solid"/>
+                      <a:round/>
+                      <a:headEnd type="none" w="med" len="med"/>
+                      <a:tailEnd type="none" w="med" len="med"/>
+                    </a:lnL>
+                    <a:lnR w="6350" cap="flat" cmpd="sng" algn="ctr">
+                      <a:solidFill>
+                        <a:srgbClr val="DEE2E6"/>
+                      </a:solidFill>
+                      <a:prstDash val="solid"/>
+                      <a:round/>
+                      <a:headEnd type="none" w="med" len="med"/>
+                      <a:tailEnd type="none" w="med" len="med"/>
+                    </a:lnR>
+                    <a:lnT w="6350" cap="flat" cmpd="sng" algn="ctr">
+                      <a:solidFill>
+                        <a:srgbClr val="DEE2E6"/>
+                      </a:solidFill>
+                      <a:prstDash val="solid"/>
+                      <a:round/>
+                      <a:headEnd type="none" w="med" len="med"/>
+                      <a:tailEnd type="none" w="med" len="med"/>
+                    </a:lnT>
+                    <a:lnB w="6350" cap="flat" cmpd="sng" algn="ctr">
+                      <a:solidFill>
+                        <a:srgbClr val="DEE2E6"/>
+                      </a:solidFill>
+                      <a:prstDash val="solid"/>
+                      <a:round/>
+                      <a:headEnd type="none" w="med" len="med"/>
+                      <a:tailEnd type="none" w="med" len="med"/>
+                    </a:lnB>
+                    <a:solidFill>
                       <a:srgbClr val="FFFFFF"/>
                     </a:solidFill>
                   </a:tcPr>
@@ -7095,7 +7143,7 @@
                           <a:ea typeface="Calibri" pitchFamily="34" charset="-122"/>
                           <a:cs typeface="Calibri" pitchFamily="34" charset="-120"/>
                         </a:rPr>
-                        <a:t>★★★</a:t>
+                        <a:t>★★★★</a:t>
                       </a:r>
                       <a:endParaRPr lang="en-US" sz="1000" dirty="0">
                         <a:latin typeface="Calibri" charset="0"/>
@@ -7233,7 +7281,7 @@
                           <a:ea typeface="Calibri" pitchFamily="34" charset="-122"/>
                           <a:cs typeface="Calibri" pitchFamily="34" charset="-120"/>
                         </a:rPr>
-                        <a:t>NRA protocol for data center</a:t>
+                        <a:t>NRA protocol for community room</a:t>
                       </a:r>
                       <a:endParaRPr lang="en-US" sz="1000" dirty="0">
                         <a:latin typeface="Calibri" charset="0"/>
@@ -7390,7 +7438,7 @@
                           <a:ea typeface="Calibri" pitchFamily="34" charset="-122"/>
                           <a:cs typeface="Calibri" pitchFamily="34" charset="-120"/>
                         </a:rPr>
-                        <a:t>$5,000</a:t>
+                        <a:t>$3,000</a:t>
                       </a:r>
                       <a:endParaRPr lang="en-US" sz="1000" dirty="0">
                         <a:latin typeface="Calibri" charset="0"/>
@@ -7479,7 +7527,7 @@
                           <a:ea typeface="Calibri" pitchFamily="34" charset="-122"/>
                           <a:cs typeface="Calibri" pitchFamily="34" charset="-120"/>
                         </a:rPr>
-                        <a:t>(masks 100k kWh of</a:t>
+                        <a:t>(masks true controls savings</a:t>
                       </a:r>
                       <a:endParaRPr lang="en-US" sz="1000" dirty="0">
                         <a:latin typeface="Calibri" charset="0"/>
@@ -7500,7 +7548,7 @@
                           <a:ea typeface="Calibri" pitchFamily="34" charset="-122"/>
                           <a:cs typeface="Calibri" pitchFamily="34" charset="-120"/>
                         </a:rPr>
-                        <a:t>true savings without it)</a:t>
+                        <a:t>without pre-documentation)</a:t>
                       </a:r>
                       <a:endParaRPr lang="en-US" sz="1000" dirty="0">
                         <a:latin typeface="Calibri" charset="0"/>
@@ -7795,7 +7843,7 @@
                           <a:ea typeface="Calibri" pitchFamily="34" charset="-122"/>
                           <a:cs typeface="Calibri" pitchFamily="34" charset="-120"/>
                         </a:rPr>
-                        <a:t>ECM-2,3</a:t>
+                        <a:t>ECM-2</a:t>
                       </a:r>
                       <a:endParaRPr lang="en-US" sz="1000" dirty="0">
                         <a:latin typeface="Calibri" charset="0"/>
@@ -7863,7 +7911,7 @@
                           <a:ea typeface="Calibri" pitchFamily="34" charset="-122"/>
                           <a:cs typeface="Calibri" pitchFamily="34" charset="-120"/>
                         </a:rPr>
-                        <a:t>$12,000</a:t>
+                        <a:t>$8,000</a:t>
                       </a:r>
                       <a:endParaRPr lang="en-US" sz="1000" dirty="0">
                         <a:latin typeface="Calibri" charset="0"/>
@@ -7952,7 +8000,7 @@
                           <a:ea typeface="Calibri" pitchFamily="34" charset="-122"/>
                           <a:cs typeface="Calibri" pitchFamily="34" charset="-120"/>
                         </a:rPr>
-                        <a:t>(more data points but</a:t>
+                        <a:t>(more granularity but</a:t>
                       </a:r>
                       <a:endParaRPr lang="en-US" sz="1000" dirty="0">
                         <a:latin typeface="Calibri" charset="0"/>
@@ -8198,7 +8246,7 @@
                 <a:ea typeface="Calibri" pitchFamily="34" charset="-122"/>
                 <a:cs typeface="Calibri" pitchFamily="34" charset="-120"/>
               </a:rPr>
-              <a:t>* NRA protocol is #1 by impact: without it, data center expansion hides ~100,000 kWh of true savings.</a:t>
+              <a:t>* NRA protocol is #1 by impact: without it, community room expansion hides true controls savings.</a:t>
             </a:r>
             <a:endParaRPr lang="en-US" sz="1100" dirty="0"/>
           </a:p>
@@ -8391,7 +8439,7 @@
                 <a:ea typeface="Consolas" pitchFamily="34" charset="-122"/>
                 <a:cs typeface="Consolas" pitchFamily="34" charset="-120"/>
               </a:rPr>
-              <a:t>$2k</a:t>
+              <a:t>$1.5k</a:t>
             </a:r>
             <a:endParaRPr lang="en-US" sz="1300" dirty="0"/>
           </a:p>
@@ -8453,7 +8501,7 @@
                 <a:ea typeface="Calibri" pitchFamily="34" charset="-122"/>
                 <a:cs typeface="Calibri" pitchFamily="34" charset="-120"/>
               </a:rPr>
-              <a:t>eliminate stipulation risk</a:t>
+              <a:t>eliminate wattage stipulation risk</a:t>
             </a:r>
             <a:endParaRPr lang="en-US" sz="1000" dirty="0"/>
           </a:p>
@@ -8539,7 +8587,7 @@
                 <a:ea typeface="Consolas" pitchFamily="34" charset="-122"/>
                 <a:cs typeface="Consolas" pitchFamily="34" charset="-120"/>
               </a:rPr>
-              <a:t>$10k</a:t>
+              <a:t>$5k</a:t>
             </a:r>
             <a:endParaRPr lang="en-US" sz="1300" dirty="0"/>
           </a:p>
@@ -8581,7 +8629,7 @@
                 <a:ea typeface="Calibri" pitchFamily="34" charset="-122"/>
                 <a:cs typeface="Calibri" pitchFamily="34" charset="-120"/>
               </a:rPr>
-              <a:t>Fan submeters + regression</a:t>
+              <a:t>NRA protocol protects</a:t>
             </a:r>
             <a:endParaRPr lang="en-US" sz="1000" dirty="0"/>
           </a:p>
@@ -8601,7 +8649,7 @@
                 <a:ea typeface="Calibri" pitchFamily="34" charset="-122"/>
                 <a:cs typeface="Calibri" pitchFamily="34" charset="-120"/>
               </a:rPr>
-              <a:t>cover 80% of uncertainty</a:t>
+              <a:t>true controls savings</a:t>
             </a:r>
             <a:endParaRPr lang="en-US" sz="1000" dirty="0"/>
           </a:p>
@@ -8687,7 +8735,7 @@
                 <a:ea typeface="Consolas" pitchFamily="34" charset="-122"/>
                 <a:cs typeface="Consolas" pitchFamily="34" charset="-120"/>
               </a:rPr>
-              <a:t>$18k</a:t>
+              <a:t>$10k</a:t>
             </a:r>
             <a:endParaRPr lang="en-US" sz="1300" dirty="0"/>
           </a:p>
@@ -8729,7 +8777,7 @@
                 <a:ea typeface="Calibri" pitchFamily="34" charset="-122"/>
                 <a:cs typeface="Calibri" pitchFamily="34" charset="-120"/>
               </a:rPr>
-              <a:t>NRA protocol ensures</a:t>
+              <a:t>Inverse model + regression</a:t>
             </a:r>
             <a:endParaRPr lang="en-US" sz="1000" dirty="0"/>
           </a:p>
@@ -8749,7 +8797,7 @@
                 <a:ea typeface="Calibri" pitchFamily="34" charset="-122"/>
                 <a:cs typeface="Calibri" pitchFamily="34" charset="-120"/>
               </a:rPr>
-              <a:t>data center doesn't mask savings</a:t>
+              <a:t>covers 80% of model uncertainty</a:t>
             </a:r>
             <a:endParaRPr lang="en-US" sz="1000" dirty="0"/>
           </a:p>
@@ -8835,7 +8883,7 @@
                 <a:ea typeface="Consolas" pitchFamily="34" charset="-122"/>
                 <a:cs typeface="Consolas" pitchFamily="34" charset="-120"/>
               </a:rPr>
-              <a:t>$30k+</a:t>
+              <a:t>$20k+</a:t>
             </a:r>
             <a:endParaRPr lang="en-US" sz="1300" dirty="0"/>
           </a:p>
@@ -8954,6 +9002,10 @@
           </a:solidFill>
           <a:ln/>
         </p:spPr>
+        <p:txBody>
+          <a:bodyPr/>
+          <a:p/>
+        </p:txBody>
       </p:sp>
       <p:sp>
         <p:nvSpPr>
@@ -9020,6 +9072,10 @@
             </a:outerShdw>
           </a:effectLst>
         </p:spPr>
+        <p:txBody>
+          <a:bodyPr/>
+          <a:p/>
+        </p:txBody>
       </p:sp>
       <p:sp>
         <p:nvSpPr>
@@ -9040,6 +9096,10 @@
           </a:solidFill>
           <a:ln/>
         </p:spPr>
+        <p:txBody>
+          <a:bodyPr/>
+          <a:p/>
+        </p:txBody>
       </p:sp>
       <p:sp>
         <p:nvSpPr>
@@ -9259,6 +9319,10 @@
           </a:solidFill>
           <a:ln/>
         </p:spPr>
+        <p:txBody>
+          <a:bodyPr/>
+          <a:p/>
+        </p:txBody>
       </p:sp>
       <p:sp>
         <p:nvSpPr>
@@ -9293,7 +9357,7 @@
                 <a:ea typeface="Calibri" pitchFamily="34" charset="-122"/>
                 <a:cs typeface="Calibri" pitchFamily="34" charset="-120"/>
               </a:rPr>
-              <a:t>In Greenfield:</a:t>
+              <a:t>In Counterfactual Headquarters:</a:t>
             </a:r>
             <a:endParaRPr lang="en-US" sz="1100" dirty="0"/>
           </a:p>
@@ -9335,7 +9399,7 @@
                 <a:ea typeface="Calibri" pitchFamily="34" charset="-122"/>
                 <a:cs typeface="Calibri" pitchFamily="34" charset="-120"/>
               </a:rPr>
-              <a:t>statssheets residuals;</a:t>
+              <a:t>12-month monthly baseline;</a:t>
             </a:r>
             <a:endParaRPr lang="en-US" sz="1000" dirty="0"/>
           </a:p>
@@ -9355,7 +9419,7 @@
                 <a:ea typeface="Calibri" pitchFamily="34" charset="-122"/>
                 <a:cs typeface="Calibri" pitchFamily="34" charset="-120"/>
               </a:rPr>
-              <a:t>mv-workbench diagnostics;</a:t>
+              <a:t>change-point model fitting;</a:t>
             </a:r>
             <a:endParaRPr lang="en-US" sz="1000" dirty="0"/>
           </a:p>
@@ -9375,7 +9439,7 @@
                 <a:ea typeface="Calibri" pitchFamily="34" charset="-122"/>
                 <a:cs typeface="Calibri" pitchFamily="34" charset="-120"/>
               </a:rPr>
-              <a:t>12-month baseline regression</a:t>
+              <a:t>residual diagnostic plots</a:t>
             </a:r>
             <a:endParaRPr lang="en-US" sz="1000" dirty="0"/>
           </a:p>
@@ -9400,6 +9464,10 @@
           </a:solidFill>
           <a:ln/>
         </p:spPr>
+        <p:txBody>
+          <a:bodyPr/>
+          <a:p/>
+        </p:txBody>
       </p:sp>
       <p:sp>
         <p:nvSpPr>
@@ -9434,7 +9502,7 @@
                 <a:ea typeface="Consolas" pitchFamily="34" charset="-122"/>
                 <a:cs typeface="Consolas" pitchFamily="34" charset="-120"/>
               </a:rPr>
-              <a:t>mv-workbench</a:t>
+              <a:t/>
             </a:r>
             <a:endParaRPr lang="en-US" sz="1000" dirty="0"/>
           </a:p>
@@ -9466,6 +9534,10 @@
             </a:outerShdw>
           </a:effectLst>
         </p:spPr>
+        <p:txBody>
+          <a:bodyPr/>
+          <a:p/>
+        </p:txBody>
       </p:sp>
       <p:sp>
         <p:nvSpPr>
@@ -9486,6 +9558,10 @@
           </a:solidFill>
           <a:ln/>
         </p:spPr>
+        <p:txBody>
+          <a:bodyPr/>
+          <a:p/>
+        </p:txBody>
       </p:sp>
       <p:sp>
         <p:nvSpPr>
@@ -9725,6 +9801,10 @@
           </a:solidFill>
           <a:ln/>
         </p:spPr>
+        <p:txBody>
+          <a:bodyPr/>
+          <a:p/>
+        </p:txBody>
       </p:sp>
       <p:sp>
         <p:nvSpPr>
@@ -9759,7 +9839,7 @@
                 <a:ea typeface="Calibri" pitchFamily="34" charset="-122"/>
                 <a:cs typeface="Calibri" pitchFamily="34" charset="-120"/>
               </a:rPr>
-              <a:t>In Greenfield:</a:t>
+              <a:t>In Counterfactual Headquarters:</a:t>
             </a:r>
             <a:endParaRPr lang="en-US" sz="1100" dirty="0"/>
           </a:p>
@@ -9801,7 +9881,7 @@
                 <a:ea typeface="Calibri" pitchFamily="34" charset="-122"/>
                 <a:cs typeface="Calibri" pitchFamily="34" charset="-120"/>
               </a:rPr>
-              <a:t>LED spot measurement;</a:t>
+              <a:t>LED wattage spot measurements;</a:t>
             </a:r>
             <a:endParaRPr lang="en-US" sz="1000" dirty="0"/>
           </a:p>
@@ -9821,7 +9901,7 @@
                 <a:ea typeface="Calibri" pitchFamily="34" charset="-122"/>
                 <a:cs typeface="Calibri" pitchFamily="34" charset="-120"/>
               </a:rPr>
-              <a:t>VFD continuous metering;</a:t>
+              <a:t>inverse model with monthly data;</a:t>
             </a:r>
             <a:endParaRPr lang="en-US" sz="1000" dirty="0"/>
           </a:p>
@@ -9841,7 +9921,7 @@
                 <a:ea typeface="Calibri" pitchFamily="34" charset="-122"/>
                 <a:cs typeface="Calibri" pitchFamily="34" charset="-120"/>
               </a:rPr>
-              <a:t>bayesian-mv-module posteriors</a:t>
+              <a:t>GoF statistics (R², CV(RMSE))</a:t>
             </a:r>
             <a:endParaRPr lang="en-US" sz="1000" dirty="0"/>
           </a:p>
@@ -9866,6 +9946,10 @@
           </a:solidFill>
           <a:ln/>
         </p:spPr>
+        <p:txBody>
+          <a:bodyPr/>
+          <a:p/>
+        </p:txBody>
       </p:sp>
       <p:sp>
         <p:nvSpPr>
@@ -9900,7 +9984,7 @@
                 <a:ea typeface="Consolas" pitchFamily="34" charset="-122"/>
                 <a:cs typeface="Consolas" pitchFamily="34" charset="-120"/>
               </a:rPr>
-              <a:t>bayesian-mv-module</a:t>
+              <a:t/>
             </a:r>
             <a:endParaRPr lang="en-US" sz="1000" dirty="0"/>
           </a:p>
@@ -9932,6 +10016,10 @@
             </a:outerShdw>
           </a:effectLst>
         </p:spPr>
+        <p:txBody>
+          <a:bodyPr/>
+          <a:p/>
+        </p:txBody>
       </p:sp>
       <p:sp>
         <p:nvSpPr>
@@ -9952,6 +10040,10 @@
           </a:solidFill>
           <a:ln/>
         </p:spPr>
+        <p:txBody>
+          <a:bodyPr/>
+          <a:p/>
+        </p:txBody>
       </p:sp>
       <p:sp>
         <p:nvSpPr>
@@ -10191,6 +10283,10 @@
           </a:solidFill>
           <a:ln/>
         </p:spPr>
+        <p:txBody>
+          <a:bodyPr/>
+          <a:p/>
+        </p:txBody>
       </p:sp>
       <p:sp>
         <p:nvSpPr>
@@ -10225,7 +10321,7 @@
                 <a:ea typeface="Calibri" pitchFamily="34" charset="-122"/>
                 <a:cs typeface="Calibri" pitchFamily="34" charset="-120"/>
               </a:rPr>
-              <a:t>In Greenfield:</a:t>
+              <a:t>In Counterfactual Headquarters:</a:t>
             </a:r>
             <a:endParaRPr lang="en-US" sz="1100" dirty="0"/>
           </a:p>
@@ -10267,7 +10363,7 @@
                 <a:ea typeface="Calibri" pitchFamily="34" charset="-122"/>
                 <a:cs typeface="Calibri" pitchFamily="34" charset="-120"/>
               </a:rPr>
-              <a:t>Data center expansion;</a:t>
+              <a:t>Community room expansion;</a:t>
             </a:r>
             <a:endParaRPr lang="en-US" sz="1000" dirty="0"/>
           </a:p>
@@ -10287,7 +10383,7 @@
                 <a:ea typeface="Calibri" pitchFamily="34" charset="-122"/>
                 <a:cs typeface="Calibri" pitchFamily="34" charset="-120"/>
               </a:rPr>
-              <a:t>entropy-audit-tool Critical zones;</a:t>
+              <a:t>NRA pre-documentation;</a:t>
             </a:r>
             <a:endParaRPr lang="en-US" sz="1000" dirty="0"/>
           </a:p>
@@ -10307,7 +10403,7 @@
                 <a:ea typeface="Calibri" pitchFamily="34" charset="-122"/>
                 <a:cs typeface="Calibri" pitchFamily="34" charset="-120"/>
               </a:rPr>
-              <a:t>CMVP_JTA governance</a:t>
+              <a:t>Professional judgment protocol</a:t>
             </a:r>
             <a:endParaRPr lang="en-US" sz="1000" dirty="0"/>
           </a:p>
@@ -10332,6 +10428,10 @@
           </a:solidFill>
           <a:ln/>
         </p:spPr>
+        <p:txBody>
+          <a:bodyPr/>
+          <a:p/>
+        </p:txBody>
       </p:sp>
       <p:sp>
         <p:nvSpPr>
@@ -10366,7 +10466,7 @@
                 <a:ea typeface="Consolas" pitchFamily="34" charset="-122"/>
                 <a:cs typeface="Consolas" pitchFamily="34" charset="-120"/>
               </a:rPr>
-              <a:t>entropy-audit-tool</a:t>
+              <a:t/>
             </a:r>
             <a:endParaRPr lang="en-US" sz="1000" dirty="0"/>
           </a:p>
@@ -10423,6 +10523,10 @@
           </a:solidFill>
           <a:ln/>
         </p:spPr>
+        <p:txBody>
+          <a:bodyPr/>
+          <a:p/>
+        </p:txBody>
       </p:sp>
       <p:sp>
         <p:nvSpPr>
@@ -10482,6 +10586,10 @@
           </a:solidFill>
           <a:ln/>
         </p:spPr>
+        <p:txBody>
+          <a:bodyPr/>
+          <a:p/>
+        </p:txBody>
       </p:sp>
       <p:sp>
         <p:nvSpPr>
@@ -10583,6 +10691,10 @@
           </a:solidFill>
           <a:ln/>
         </p:spPr>
+        <p:txBody>
+          <a:bodyPr/>
+          <a:p/>
+        </p:txBody>
       </p:sp>
       <p:sp>
         <p:nvSpPr>
@@ -10659,7 +10771,7 @@
                 <a:ea typeface="Calibri" pitchFamily="34" charset="-122"/>
                 <a:cs typeface="Calibri" pitchFamily="34" charset="-120"/>
               </a:rPr>
-              <a:t>Prioritize by marginal benefit-to-cost ratio, not by ECM size. The NRA protocol ($5k) may be the single highest-value investment.</a:t>
+              <a:t>Prioritize by marginal benefit-to-cost ratio, not by ECM size. The NRA protocol ($3k) may be the single highest-value investment.</a:t>
             </a:r>
             <a:endParaRPr lang="en-US" sz="1500" dirty="0"/>
           </a:p>
@@ -10684,6 +10796,10 @@
           </a:solidFill>
           <a:ln/>
         </p:spPr>
+        <p:txBody>
+          <a:bodyPr/>
+          <a:p/>
+        </p:txBody>
       </p:sp>
       <p:sp>
         <p:nvSpPr>
@@ -10785,6 +10901,10 @@
           </a:solidFill>
           <a:ln/>
         </p:spPr>
+        <p:txBody>
+          <a:bodyPr/>
+          <a:p/>
+        </p:txBody>
       </p:sp>
       <p:sp>
         <p:nvSpPr>
@@ -10886,6 +11006,10 @@
           </a:solidFill>
           <a:ln/>
         </p:spPr>
+        <p:txBody>
+          <a:bodyPr/>
+          <a:p/>
+        </p:txBody>
       </p:sp>
       <p:sp>
         <p:nvSpPr>
@@ -10920,7 +11044,7 @@
                 <a:ea typeface="Calibri" pitchFamily="34" charset="-122"/>
                 <a:cs typeface="Calibri" pitchFamily="34" charset="-120"/>
               </a:rPr>
-              <a:t>counterfactual-designs.com  |  cmvp-capstone.vercel.app  |  mnvexample.streamlit.app</a:t>
+              <a:t>counterfactual-designs.com  |  cmvp-capstone.vercel.app</a:t>
             </a:r>
             <a:endParaRPr lang="en-US" sz="1000" dirty="0"/>
           </a:p>

</xml_diff>